<commit_message>
Pitch deck in Russian for the jury
Co-Authored-By: Claude Opus 5.5 <noreply@anthropic.com>
Claude-Session: https://claude.ai/code/session_01SLBLD9Vkf4ZQaUJTcpWdVb
</commit_message>
<xml_diff>
--- a/docs/CashLint-pitch.pptx
+++ b/docs/CashLint-pitch.pptx
@@ -3173,7 +3173,7 @@
                   <a:srgbClr val="141B2D"/>
                 </a:solidFill>
               </a:rPr>
-              <a:t>CashLint: local AI review of cash-desk video</a:t>
+              <a:t>CashLint: локальный ИИ-анализ видео кассовых операций</a:t>
             </a:r>
           </a:p>
         </p:txBody>
@@ -3211,7 +3211,7 @@
                   <a:srgbClr val="5B6478"/>
                 </a:solidFill>
               </a:rPr>
-              <a:t>Upload a cash-desk recording, get a verdict, typed violations, timecodes,</a:t>
+              <a:t>Загрузите запись с камеры кассы и примерно за минуту получите вердикт, тип нарушения,</a:t>
             </a:r>
           </a:p>
           <a:p>
@@ -3226,7 +3226,7 @@
                   <a:srgbClr val="5B6478"/>
                 </a:solidFill>
               </a:rPr>
-              <a:t>evidence frames and the exact НБРК №231 clause, in about a minute.</a:t>
+              <a:t>таймкод, кадры-доказательства и точный пункт НБРК №231.</a:t>
             </a:r>
           </a:p>
           <a:p>
@@ -3256,7 +3256,7 @@
                   <a:srgbClr val="5B6478"/>
                 </a:solidFill>
               </a:rPr>
-              <a:t>Open-weight model on our own GPU. No cloud AI, no face identification, works offline.</a:t>
+              <a:t>Открытая модель на нашем собственном GPU. Без облачного ИИ и распознавания лиц, работает офлайн.</a:t>
             </a:r>
           </a:p>
         </p:txBody>
@@ -3320,7 +3320,7 @@
                   <a:srgbClr val="0B7A5C"/>
                 </a:solidFill>
               </a:rPr>
-              <a:t>WHY IT MATTERS</a:t>
+              <a:t>ЗАЧЕМ ЭТО НУЖНО</a:t>
             </a:r>
           </a:p>
         </p:txBody>
@@ -3358,7 +3358,7 @@
                   <a:srgbClr val="141B2D"/>
                 </a:solidFill>
               </a:rPr>
-              <a:t>The problem</a:t>
+              <a:t>Проблема</a:t>
             </a:r>
           </a:p>
         </p:txBody>
@@ -3396,7 +3396,7 @@
                   <a:srgbClr val="141B2D"/>
                 </a:solidFill>
               </a:rPr>
-              <a:t>• Cash-desk procedure violations are found by people re-watching CCTV: slow and inconsistent.</a:t>
+              <a:t>• Нарушения кассовых процедур ищут вручную, пересматривая записи камер: долго и непоследовательно.</a:t>
             </a:r>
           </a:p>
           <a:p>
@@ -3411,7 +3411,7 @@
                   <a:srgbClr val="141B2D"/>
                 </a:solidFill>
               </a:rPr>
-              <a:t>• A useful tool must be local (bank footage never leaves), explainable, and cite the actual rule.</a:t>
+              <a:t>• Полезный инструмент должен работать локально (видео банка не покидает контур), объяснять решение и ссылаться на норму.</a:t>
             </a:r>
           </a:p>
           <a:p>
@@ -3426,7 +3426,7 @@
                   <a:srgbClr val="141B2D"/>
                 </a:solidFill>
               </a:rPr>
-              <a:t>• It must never invent a violation it cannot see, or a legal norm that does not apply.</a:t>
+              <a:t>• Он не должен выдумывать нарушение, которого не видно, или норму, которая не применяется.</a:t>
             </a:r>
           </a:p>
         </p:txBody>
@@ -3490,7 +3490,7 @@
                   <a:srgbClr val="0B7A5C"/>
                 </a:solidFill>
               </a:rPr>
-              <a:t>ARCHITECTURE</a:t>
+              <a:t>АРХИТЕКТУРА</a:t>
             </a:r>
           </a:p>
         </p:txBody>
@@ -3528,7 +3528,7 @@
                   <a:srgbClr val="141B2D"/>
                 </a:solidFill>
               </a:rPr>
-              <a:t>How it works</a:t>
+              <a:t>Как это работает</a:t>
             </a:r>
           </a:p>
         </p:txBody>
@@ -3566,7 +3566,7 @@
                   <a:srgbClr val="141B2D"/>
                 </a:solidFill>
               </a:rPr>
-              <a:t>1. Frame sampling: 16 overview images with source timestamps</a:t>
+              <a:t>1. Выборка кадров: 16 обзорных изображений с исходными таймкодами</a:t>
             </a:r>
           </a:p>
           <a:p>
@@ -3581,7 +3581,7 @@
                   <a:srgbClr val="141B2D"/>
                 </a:solidFill>
               </a:rPr>
-              <a:t>2. Qwen3-VL-32B-Instruct-AWQ sweep → typed candidate events (14 case types)</a:t>
+              <a:t>2. Обзор моделью Qwen3-VL-32B-Instruct-AWQ: кандидаты событий по 14 типам из кейса</a:t>
             </a:r>
           </a:p>
           <a:p>
@@ -3596,7 +3596,7 @@
                   <a:srgbClr val="141B2D"/>
                 </a:solidFill>
               </a:rPr>
-              <a:t>3. Dense focused confirmation of each proposal: rejects unsupported concerns</a:t>
+              <a:t>3. Плотная перепроверка каждого кандидата: неподтверждённое отбрасывается</a:t>
             </a:r>
           </a:p>
           <a:p>
@@ -3611,7 +3611,7 @@
                   <a:srgbClr val="141B2D"/>
                 </a:solidFill>
               </a:rPr>
-              <a:t>4. Storage veto: counter-examples for "cash/safe left out" cut false alarms 6 → 3</a:t>
+              <a:t>4. Контрпримеры хранения для «деньги/сейф без присмотра»: ложные срабатывания 6 → 3</a:t>
             </a:r>
           </a:p>
           <a:p>
@@ -3626,7 +3626,7 @@
                   <a:srgbClr val="141B2D"/>
                 </a:solidFill>
               </a:rPr>
-              <a:t>5. Rescue pass: phase-shifted second sweep re-checks missed and uncertain events</a:t>
+              <a:t>5. Повторный проход со сдвигом кадров находит пропущенные и сомнительные события</a:t>
             </a:r>
           </a:p>
           <a:p>
@@ -3641,7 +3641,7 @@
                   <a:srgbClr val="141B2D"/>
                 </a:solidFill>
               </a:rPr>
-              <a:t>6. Result: verdict, type, timecode, evidence JPEGs, cited clause, human-review caveat</a:t>
+              <a:t>6. Результат: вердикт, тип, таймкод, кадры-доказательства, цитата нормы, пометка о проверке человеком</a:t>
             </a:r>
           </a:p>
           <a:p>
@@ -3671,7 +3671,7 @@
                   <a:srgbClr val="141B2D"/>
                 </a:solidFill>
               </a:rPr>
-              <a:t>FastAPI async jobs · vLLM on one A40 · model port never exposed · 185 s budget inside 5 min</a:t>
+              <a:t>FastAPI, асинхронные задачи · vLLM на одной A40 · порт модели не открыт наружу · бюджет 185 с из 5 минут</a:t>
             </a:r>
           </a:p>
         </p:txBody>
@@ -3735,7 +3735,7 @@
                   <a:srgbClr val="0B7A5C"/>
                 </a:solidFill>
               </a:rPr>
-              <a:t>REAL RUNS, FROZEN EVALUATOR</a:t>
+              <a:t>РЕАЛЬНЫЕ ПРОГОНЫ, НЕИЗМЕННЫЙ ОЦЕНЩИК</a:t>
             </a:r>
           </a:p>
         </p:txBody>
@@ -3773,7 +3773,7 @@
                   <a:srgbClr val="141B2D"/>
                 </a:solidFill>
               </a:rPr>
-              <a:t>Measured results</a:t>
+              <a:t>Измеренные результаты</a:t>
             </a:r>
           </a:p>
         </p:txBody>
@@ -3797,10 +3797,10 @@
                 <a:tableStyleId>{5C22544A-7EE6-4342-B048-85BDC9FD1C3A}</a:tableStyleId>
               </a:tblPr>
               <a:tblGrid>
-                <a:gridCol w="3291840"/>
-                <a:gridCol w="1371600"/>
-                <a:gridCol w="1371600"/>
-                <a:gridCol w="2651760"/>
+                <a:gridCol w="3566160"/>
+                <a:gridCol w="1280160"/>
+                <a:gridCol w="1280160"/>
+                <a:gridCol w="2560320"/>
                 <a:gridCol w="2194560"/>
               </a:tblGrid>
               <a:tr h="457200">
@@ -3815,7 +3815,7 @@
                             <a:srgbClr val="FFFFFF"/>
                           </a:solidFill>
                         </a:rPr>
-                        <a:t>Recipe</a:t>
+                        <a:t>Конфигурация</a:t>
                       </a:r>
                     </a:p>
                   </a:txBody>
@@ -3836,7 +3836,7 @@
                             <a:srgbClr val="FFFFFF"/>
                           </a:solidFill>
                         </a:rPr>
-                        <a:t>Data</a:t>
+                        <a:t>Данные</a:t>
                       </a:r>
                     </a:p>
                   </a:txBody>
@@ -3857,7 +3857,7 @@
                             <a:srgbClr val="FFFFFF"/>
                           </a:solidFill>
                         </a:rPr>
-                        <a:t>Correct</a:t>
+                        <a:t>Верно</a:t>
                       </a:r>
                     </a:p>
                   </a:txBody>
@@ -3899,7 +3899,7 @@
                             <a:srgbClr val="FFFFFF"/>
                           </a:solidFill>
                         </a:rPr>
-                        <a:t>Timed ±2 s</a:t>
+                        <a:t>Таймкод ±2 с</a:t>
                       </a:r>
                     </a:p>
                   </a:txBody>
@@ -3922,7 +3922,7 @@
                             <a:srgbClr val="141B2D"/>
                           </a:solidFill>
                         </a:rPr>
-                        <a:t>Original 8B</a:t>
+                        <a:t>Исходная 8B</a:t>
                       </a:r>
                     </a:p>
                   </a:txBody>
@@ -4029,7 +4029,7 @@
                             <a:srgbClr val="141B2D"/>
                           </a:solidFill>
                         </a:rPr>
-                        <a:t>32B proposal policy</a:t>
+                        <a:t>32B, политика предложений</a:t>
                       </a:r>
                     </a:p>
                   </a:txBody>
@@ -4136,7 +4136,7 @@
                             <a:srgbClr val="141B2D"/>
                           </a:solidFill>
                         </a:rPr>
-                        <a:t>+ storage veto (selected)</a:t>
+                        <a:t>+ контрпримеры хранения (основная)</a:t>
                       </a:r>
                     </a:p>
                   </a:txBody>
@@ -4243,7 +4243,7 @@
                             <a:srgbClr val="141B2D"/>
                           </a:solidFill>
                         </a:rPr>
-                        <a:t>+ rescue recall pass</a:t>
+                        <a:t>+ повторный проход</a:t>
                       </a:r>
                     </a:p>
                   </a:txBody>
@@ -4350,7 +4350,7 @@
                             <a:srgbClr val="141B2D"/>
                           </a:solidFill>
                         </a:rPr>
-                        <a:t>+ rescue recall pass</a:t>
+                        <a:t>+ повторный проход</a:t>
                       </a:r>
                     </a:p>
                   </a:txBody>
@@ -4371,7 +4371,7 @@
                             <a:srgbClr val="141B2D"/>
                           </a:solidFill>
                         </a:rPr>
-                        <a:t>all 40</a:t>
+                        <a:t>все 40</a:t>
                       </a:r>
                     </a:p>
                   </a:txBody>
@@ -4482,7 +4482,7 @@
                   <a:srgbClr val="5B6478"/>
                 </a:solidFill>
               </a:rPr>
-              <a:t>Every event matched in time has the correct type. Public API on all 40 videos: 0 failed jobs, slowest 73 s, within the 5-minute limit.</a:t>
+              <a:t>Каждое событие, найденное в нужное время, классифицировано верно. Публичный API на всех 40 видео: 0 ошибок, самое долгое 73 с из 5 минут.</a:t>
             </a:r>
           </a:p>
           <a:p>
@@ -4497,7 +4497,7 @@
                   <a:srgbClr val="5B6478"/>
                 </a:solidFill>
               </a:rPr>
-              <a:t>All 40 recordings were reviewed during development, so these are not independent test scores.</a:t>
+              <a:t>Все 40 записей просматривались при разработке, поэтому это не независимая тестовая оценка.</a:t>
             </a:r>
           </a:p>
         </p:txBody>
@@ -4561,7 +4561,7 @@
                   <a:srgbClr val="0B7A5C"/>
                 </a:solidFill>
               </a:rPr>
-              <a:t>RULE GROUNDING</a:t>
+              <a:t>ПРАВОВОЕ ОБОСНОВАНИЕ</a:t>
             </a:r>
           </a:p>
         </p:txBody>
@@ -4599,7 +4599,7 @@
                   <a:srgbClr val="141B2D"/>
                 </a:solidFill>
               </a:rPr>
-              <a:t>Rule grounding without invention</a:t>
+              <a:t>Нормы без выдумок</a:t>
             </a:r>
           </a:p>
         </p:txBody>
@@ -4623,8 +4623,8 @@
                 <a:tableStyleId>{5C22544A-7EE6-4342-B048-85BDC9FD1C3A}</a:tableStyleId>
               </a:tblPr>
               <a:tblGrid>
-                <a:gridCol w="4937760"/>
-                <a:gridCol w="5943600"/>
+                <a:gridCol w="5120640"/>
+                <a:gridCol w="5760720"/>
               </a:tblGrid>
               <a:tr h="457200">
                 <a:tc>
@@ -4638,7 +4638,7 @@
                             <a:srgbClr val="FFFFFF"/>
                           </a:solidFill>
                         </a:rPr>
-                        <a:t>Violation type</a:t>
+                        <a:t>Тип нарушения</a:t>
                       </a:r>
                     </a:p>
                   </a:txBody>
@@ -4659,7 +4659,7 @@
                             <a:srgbClr val="FFFFFF"/>
                           </a:solidFill>
                         </a:rPr>
-                        <a:t>НБРК №231 clause (exact quote in every result)</a:t>
+                        <a:t>Пункт НБРК №231 (точная цитата в каждом результате)</a:t>
                       </a:r>
                     </a:p>
                   </a:txBody>
@@ -4682,7 +4682,7 @@
                             <a:srgbClr val="141B2D"/>
                           </a:solidFill>
                         </a:rPr>
-                        <a:t>Cash left outside storage, safe left open</a:t>
+                        <a:t>Наличные вне хранилища, сейф открыт</a:t>
                       </a:r>
                     </a:p>
                   </a:txBody>
@@ -4703,7 +4703,7 @@
                             <a:srgbClr val="141B2D"/>
                           </a:solidFill>
                         </a:rPr>
-                        <a:t>п.20 ч.2: accepted cash is kept in lockable storage</a:t>
+                        <a:t>п.20 ч.2: принятые наличные хранятся в устройствах, закрывающихся на ключ</a:t>
                       </a:r>
                     </a:p>
                   </a:txBody>
@@ -4726,7 +4726,7 @@
                             <a:srgbClr val="141B2D"/>
                           </a:solidFill>
                         </a:rPr>
-                        <a:t>Counting without the client</a:t>
+                        <a:t>Пересчёт без клиента</a:t>
                       </a:r>
                     </a:p>
                   </a:txBody>
@@ -4747,7 +4747,7 @@
                             <a:srgbClr val="141B2D"/>
                           </a:solidFill>
                         </a:rPr>
-                        <a:t>п.20 ч.1: cash is accepted and counted in the client's presence</a:t>
+                        <a:t>п.20 ч.1: наличные принимаются и пересчитываются в присутствии клиента</a:t>
                       </a:r>
                     </a:p>
                   </a:txBody>
@@ -4770,7 +4770,7 @@
                             <a:srgbClr val="141B2D"/>
                           </a:solidFill>
                         </a:rPr>
-                        <a:t>No note-by-note count / no ID check / no receipt</a:t>
+                        <a:t>Нет полистного пересчёта / проверки личности / документа клиенту</a:t>
                       </a:r>
                     </a:p>
                   </a:txBody>
@@ -4814,7 +4814,7 @@
                             <a:srgbClr val="141B2D"/>
                           </a:solidFill>
                         </a:rPr>
-                        <a:t>Personal items in the cash unit</a:t>
+                        <a:t>Личные вещи в кассовом узле</a:t>
                       </a:r>
                     </a:p>
                   </a:txBody>
@@ -4883,7 +4883,7 @@
                   <a:srgbClr val="5B6478"/>
                 </a:solidFill>
               </a:rPr>
-              <a:t>Official Adilet text, current revision, SHA-256 recorded per quote.</a:t>
+              <a:t>Официальный текст Adilet, действующая редакция, SHA-256 сохранён для каждой цитаты.</a:t>
             </a:r>
           </a:p>
           <a:p>
@@ -4898,7 +4898,7 @@
                   <a:srgbClr val="5B6478"/>
                 </a:solidFill>
               </a:rPr>
-              <a:t>Door, keys, food and reading have no directly applicable clause, so we make no legal claim for them.</a:t>
+              <a:t>Для двери, ключей, еды и чтения прямо применимой нормы нет, поэтому правовых утверждений по ним мы не делаем.</a:t>
             </a:r>
           </a:p>
         </p:txBody>
@@ -4962,7 +4962,7 @@
                   <a:srgbClr val="0B7A5C"/>
                 </a:solidFill>
               </a:rPr>
-              <a:t>TECHNICAL SOLUTION</a:t>
+              <a:t>ТЕХНИЧЕСКОЕ РЕШЕНИЕ</a:t>
             </a:r>
           </a:p>
         </p:txBody>
@@ -5000,7 +5000,7 @@
                   <a:srgbClr val="141B2D"/>
                 </a:solidFill>
               </a:rPr>
-              <a:t>Local, licensed, deployable</a:t>
+              <a:t>Локально, лицензионно, готово к работе</a:t>
             </a:r>
           </a:p>
         </p:txBody>
@@ -5038,7 +5038,7 @@
                   <a:srgbClr val="141B2D"/>
                 </a:solidFill>
               </a:rPr>
-              <a:t>• Network-denied GPU run passed on the selected recipe</a:t>
+              <a:t>• Прогон на GPU с заблокированной сетью пройден на основной конфигурации</a:t>
             </a:r>
           </a:p>
           <a:p>
@@ -5053,7 +5053,7 @@
                   <a:srgbClr val="141B2D"/>
                 </a:solidFill>
               </a:rPr>
-              <a:t>• Licence verifier: all 238 installed packages + CPython + FFmpeg + model weights, 0 failures</a:t>
+              <a:t>• Проверка лицензий: 238 пакетов + CPython + FFmpeg + веса модели, 0 нарушений</a:t>
             </a:r>
           </a:p>
           <a:p>
@@ -5068,7 +5068,7 @@
                   <a:srgbClr val="141B2D"/>
                 </a:solidFill>
               </a:rPr>
-              <a:t>  (open source, commercial use permitted; model weights Apache-2.0)</a:t>
+              <a:t>  (открытый код, коммерческое использование разрешено; веса модели под Apache-2.0)</a:t>
             </a:r>
           </a:p>
           <a:p>
@@ -5083,7 +5083,7 @@
                   <a:srgbClr val="141B2D"/>
                 </a:solidFill>
               </a:rPr>
-              <a:t>• Every experiment logged, including the ones we dropped</a:t>
+              <a:t>• Каждый эксперимент записан в журнал, включая отклонённые</a:t>
             </a:r>
           </a:p>
           <a:p>
@@ -5098,7 +5098,7 @@
                   <a:srgbClr val="141B2D"/>
                 </a:solidFill>
               </a:rPr>
-              <a:t>• 1234 automated tests; recipe pinned in deploy/mission-best.env</a:t>
+              <a:t>• 1234 автотеста; конфигурация зафиксирована в deploy/mission-best.env</a:t>
             </a:r>
           </a:p>
         </p:txBody>
@@ -5162,7 +5162,7 @@
                   <a:srgbClr val="0B7A5C"/>
                 </a:solidFill>
               </a:rPr>
-              <a:t>HONEST LIMITS</a:t>
+              <a:t>ЧЕСТНЫЕ ОГРАНИЧЕНИЯ</a:t>
             </a:r>
           </a:p>
         </p:txBody>
@@ -5200,7 +5200,7 @@
                   <a:srgbClr val="141B2D"/>
                 </a:solidFill>
               </a:rPr>
-              <a:t>What we learned and what is next</a:t>
+              <a:t>Выводы и следующие шаги</a:t>
             </a:r>
           </a:p>
         </p:txBody>
@@ -5238,7 +5238,7 @@
                   <a:srgbClr val="141B2D"/>
                 </a:solidFill>
               </a:rPr>
-              <a:t>• Timing: lasting states (cash out, door open) are flagged when first visible, not when</a:t>
+              <a:t>• Таймкоды: длящиеся состояния (деньги на столе, открытая дверь) отмечаются при первом появлении,</a:t>
             </a:r>
           </a:p>
           <a:p>
@@ -5253,7 +5253,7 @@
                   <a:srgbClr val="141B2D"/>
                 </a:solidFill>
               </a:rPr>
-              <a:t>  they become a violation. Two model-based re-timing attempts made it worse, so we kept the safer version.</a:t>
+              <a:t>  а не в момент, когда они становятся нарушением. Две попытки уточнить время моделью ухудшили результат.</a:t>
             </a:r>
           </a:p>
           <a:p>
@@ -5268,7 +5268,7 @@
                   <a:srgbClr val="141B2D"/>
                 </a:solidFill>
               </a:rPr>
-              <a:t>• Omissions (no receipt, no ID check) are never inferred from frames we did not see.</a:t>
+              <a:t>• Пропущенные действия (нет документа клиенту, нет проверки личности) не выводятся из кадров, которых мы не видели.</a:t>
             </a:r>
           </a:p>
           <a:p>
@@ -5283,7 +5283,7 @@
                   <a:srgbClr val="141B2D"/>
                 </a:solidFill>
               </a:rPr>
-              <a:t>• Next: person-departure cues for timing, longer focused clips for omissions,</a:t>
+              <a:t>• Дальше: время ухода сотрудника для таймкодов, более длинные фрагменты для пропусков,</a:t>
             </a:r>
           </a:p>
           <a:p>
@@ -5298,7 +5298,7 @@
                   <a:srgbClr val="141B2D"/>
                 </a:solidFill>
               </a:rPr>
-              <a:t>  and validation on a new camera layout.</a:t>
+              <a:t>  проверка на новой камере.</a:t>
             </a:r>
           </a:p>
         </p:txBody>

</xml_diff>